<commit_message>
feat: Implement initial PPTX generation capabilities with core XML structures, media handling, and comprehensive smoke test samples.
</commit_message>
<xml_diff>
--- a/smoke_samples/22_speaker_notes.pptx
+++ b/smoke_samples/22_speaker_notes.pptx
@@ -5,7 +5,7 @@
     <p:sldMasterId id="2147483648" r:id="rId1"/>
   </p:sldMasterIdLst>
   <p:notesMasterIdLst>
-    <p:notesMasterId id="2147483664" r:id="rId4"/>
+    <p:notesMasterId r:id="rId4"/>
   </p:notesMasterIdLst>
   <p:sldIdLst>
     <p:sldId id="257" r:id="rId3"/>
@@ -617,4 +617,200 @@
   <a:objectDefaults/>
   <a:extraClrSchemeLst/>
 </a:theme>
+</file>
+
+<file path=ppt/theme/theme2.xml><?xml version="1.0" encoding="utf-8"?>
+<a:theme xmlns:a="http://schemas.openxmlformats.org/drawingml/2006/main" name="Office Theme">
+  <a:themeElements>
+    <a:clrScheme name="Office">
+      <a:dk1>
+        <a:sysClr val="windowText" lastClr="000000"/>
+      </a:dk1>
+      <a:lt1>
+        <a:sysClr val="window" lastClr="FFFFFF"/>
+      </a:lt1>
+      <a:dk2>
+        <a:srgbClr val="1F497D"/>
+      </a:dk2>
+      <a:lt2>
+        <a:srgbClr val="EEECE1"/>
+      </a:lt2>
+      <a:accent1>
+        <a:srgbClr val="4F81BD"/>
+      </a:accent1>
+      <a:accent2>
+        <a:srgbClr val="C0504D"/>
+      </a:accent2>
+      <a:accent3>
+        <a:srgbClr val="9BBB59"/>
+      </a:accent3>
+      <a:accent4>
+        <a:srgbClr val="8064A2"/>
+      </a:accent4>
+      <a:accent5>
+        <a:srgbClr val="4BACC6"/>
+      </a:accent5>
+      <a:accent6>
+        <a:srgbClr val="F79646"/>
+      </a:accent6>
+      <a:hlink>
+        <a:srgbClr val="0000FF"/>
+      </a:hlink>
+      <a:folHlink>
+        <a:srgbClr val="800080"/>
+      </a:folHlink>
+    </a:clrScheme>
+    <a:fontScheme name="Office">
+      <a:majorFont>
+        <a:latin typeface="Calibri"/>
+        <a:ea typeface=""/>
+        <a:cs typeface=""/>
+      </a:majorFont>
+      <a:minorFont>
+        <a:latin typeface="Calibri"/>
+        <a:ea typeface=""/>
+        <a:cs typeface=""/>
+      </a:minorFont>
+    </a:fontScheme>
+    <a:fmtScheme name="Office">
+      <a:fillStyleLst>
+        <a:solidFill>
+          <a:schemeClr val="phClr"/>
+        </a:solidFill>
+        <a:gradFill rotWithShape="1">
+          <a:gsLst>
+            <a:gs pos="0">
+              <a:schemeClr val="phClr">
+                <a:tint val="50000"/>
+                <a:satMod val="300000"/>
+              </a:schemeClr>
+            </a:gs>
+            <a:gs pos="35000">
+              <a:schemeClr val="phClr">
+                <a:tint val="37000"/>
+                <a:satMod val="300000"/>
+              </a:schemeClr>
+            </a:gs>
+            <a:gs pos="100000">
+              <a:schemeClr val="phClr">
+                <a:tint val="15000"/>
+                <a:satMod val="350000"/>
+              </a:schemeClr>
+            </a:gs>
+          </a:gsLst>
+          <a:lin ang="16200000" scaled="1"/>
+        </a:gradFill>
+        <a:gradFill rotWithShape="1">
+          <a:gsLst>
+            <a:gs pos="0">
+              <a:schemeClr val="phClr">
+                <a:shade val="51000"/>
+                <a:satMod val="130000"/>
+              </a:schemeClr>
+            </a:gs>
+            <a:gs pos="80000">
+              <a:schemeClr val="phClr">
+                <a:shade val="93000"/>
+                <a:satMod val="130000"/>
+              </a:schemeClr>
+            </a:gs>
+            <a:gs pos="100000">
+              <a:schemeClr val="phClr">
+                <a:shade val="94000"/>
+                <a:satMod val="135000"/>
+              </a:schemeClr>
+            </a:gs>
+          </a:gsLst>
+          <a:lin ang="16200000" scaled="0"/>
+        </a:gradFill>
+      </a:fillStyleLst>
+      <a:lnStyleLst>
+        <a:ln w="9525" cap="flat" cmpd="sng" algn="ctr">
+          <a:solidFill>
+            <a:schemeClr val="phClr">
+              <a:shade val="95000"/>
+              <a:satMod val="105000"/>
+            </a:schemeClr>
+          </a:solidFill>
+          <a:prstDash val="solid"/>
+        </a:ln>
+        <a:ln w="25400" cap="flat" cmpd="sng" algn="ctr">
+          <a:solidFill>
+            <a:schemeClr val="phClr"/>
+          </a:solidFill>
+          <a:prstDash val="solid"/>
+        </a:ln>
+        <a:ln w="38100" cap="flat" cmpd="sng" algn="ctr">
+          <a:solidFill>
+            <a:schemeClr val="phClr"/>
+          </a:solidFill>
+          <a:prstDash val="solid"/>
+        </a:ln>
+      </a:lnStyleLst>
+      <a:effectStyleLst>
+        <a:effectStyle>
+          <a:effectLst/>
+        </a:effectStyle>
+        <a:effectStyle>
+          <a:effectLst/>
+        </a:effectStyle>
+        <a:effectStyle>
+          <a:effectLst/>
+        </a:effectStyle>
+      </a:effectStyleLst>
+      <a:bgFillStyleLst>
+        <a:solidFill>
+          <a:schemeClr val="phClr"/>
+        </a:solidFill>
+        <a:gradFill rotWithShape="1">
+          <a:gsLst>
+            <a:gs pos="0">
+              <a:schemeClr val="phClr">
+                <a:tint val="40000"/>
+                <a:satMod val="350000"/>
+              </a:schemeClr>
+            </a:gs>
+            <a:gs pos="40000">
+              <a:schemeClr val="phClr">
+                <a:tint val="45000"/>
+                <a:shade val="99000"/>
+                <a:satMod val="350000"/>
+              </a:schemeClr>
+            </a:gs>
+            <a:gs pos="100000">
+              <a:schemeClr val="phClr">
+                <a:shade val="20000"/>
+                <a:satMod val="255000"/>
+              </a:schemeClr>
+            </a:gs>
+          </a:gsLst>
+          <a:path path="circle">
+            <a:fillToRect l="50000" t="-80000" r="50000" b="180000"/>
+          </a:path>
+        </a:gradFill>
+        <a:gradFill rotWithShape="1">
+          <a:gsLst>
+            <a:gs pos="0">
+              <a:schemeClr val="phClr">
+                <a:tint val="80000"/>
+                <a:satMod val="300000"/>
+              </a:schemeClr>
+            </a:gs>
+            <a:gs pos="100000">
+              <a:schemeClr val="phClr">
+                <a:shade val="30000"/>
+                <a:satMod val="200000"/>
+              </a:schemeClr>
+            </a:gs>
+          </a:gsLst>
+          <a:path path="circle">
+            <a:fillToRect l="50000" t="50000" r="50000" b="50000"/>
+          </a:path>
+        </a:gradFill>
+      </a:bgFillStyleLst>
+    </a:fmtScheme>
+  </a:themeElements>
+  <a:objectDefaults/>
+  <a:extraClrSchemeLst/>
+</a:theme>
 </file>
</xml_diff>

<commit_message>
feat: Add transitions, shape registry, and a comprehensive suite of smoke samples for various PPTX features.
</commit_message>
<xml_diff>
--- a/smoke_samples/22_speaker_notes.pptx
+++ b/smoke_samples/22_speaker_notes.pptx
@@ -101,33 +101,15 @@
           <a:bodyPr/>
           <a:lstStyle/>
           <a:p>
+            <a:pPr lvl="0" marL="457200" indent="-457200">
+              <a:buChar char="•"/>
+            </a:pPr>
             <a:r>
-              <a:rPr lang="en-US" dirty="0"/>
-              <a:t>These are speaker notes that appear in presenter view.</a:t>
-            </a:r>
-          </a:p>
-          <a:p>
-            <a:r>
-              <a:rPr lang="en-US" dirty="0"/>
-              <a:t/>
-            </a:r>
-          </a:p>
-          <a:p>
-            <a:r>
-              <a:rPr lang="en-US" dirty="0"/>
-              <a:t>Key points:</a:t>
-            </a:r>
-          </a:p>
-          <a:p>
-            <a:r>
-              <a:rPr lang="en-US" dirty="0"/>
-              <a:t>- First point</a:t>
-            </a:r>
-          </a:p>
-          <a:p>
-            <a:r>
-              <a:rPr lang="en-US" dirty="0"/>
-              <a:t>- Second point</a:t>
+              <a:rPr lang="en-US" sz="1200" b="0" i="0" u="none" dirty="0"/>
+              <a:t>These are speaker notes that appear in presenter view.
+Key points:
+- First point
+- Second point</a:t>
             </a:r>
           </a:p>
         </p:txBody>
@@ -612,200 +594,4 @@
   <a:objectDefaults/>
   <a:extraClrSchemeLst/>
 </a:theme>
-</file>
-
-<file path=ppt/theme/theme2.xml><?xml version="1.0" encoding="utf-8"?>
-<a:theme xmlns:a="http://schemas.openxmlformats.org/drawingml/2006/main" name="Office Theme marketing">
-  <a:themeElements>
-    <a:clrScheme name="Office colors">
-      <a:dk1>
-        <a:sysClr val="windowText" lastClr="000000"/>
-      </a:dk1>
-      <a:lt1>
-        <a:sysClr val="window" lastClr="FFFFFF"/>
-      </a:lt1>
-      <a:dk2>
-        <a:srgbClr val="1F497D"/>
-      </a:dk2>
-      <a:lt2>
-        <a:srgbClr val="EEECE1"/>
-      </a:lt2>
-      <a:accent1>
-        <a:srgbClr val="4F81BD"/>
-      </a:accent1>
-      <a:accent2>
-        <a:srgbClr val="C0504D"/>
-      </a:accent2>
-      <a:accent3>
-        <a:srgbClr val="9BBB59"/>
-      </a:accent3>
-      <a:accent4>
-        <a:srgbClr val="8064A2"/>
-      </a:accent4>
-      <a:accent5>
-        <a:srgbClr val="4BACC6"/>
-      </a:accent5>
-      <a:accent6>
-        <a:srgbClr val="F79646"/>
-      </a:accent6>
-      <a:hlink>
-        <a:srgbClr val="0000FF"/>
-      </a:hlink>
-      <a:folHlink>
-        <a:srgbClr val="800080"/>
-      </a:folHlink>
-    </a:clrScheme>
-    <a:fontScheme name="Office fonts">
-      <a:majorFont>
-        <a:latin typeface="Calibri"/>
-        <a:ea typeface=""/>
-        <a:cs typeface=""/>
-      </a:majorFont>
-      <a:minorFont>
-        <a:latin typeface="Calibri"/>
-        <a:ea typeface=""/>
-        <a:cs typeface=""/>
-      </a:minorFont>
-    </a:fontScheme>
-    <a:fmtScheme name="Office">
-      <a:fillStyleLst>
-        <a:solidFill>
-          <a:schemeClr val="phClr"/>
-        </a:solidFill>
-        <a:gradFill rotWithShape="1">
-          <a:gsLst>
-            <a:gs pos="0">
-              <a:schemeClr val="phClr">
-                <a:tint val="50000"/>
-                <a:satMod val="300000"/>
-              </a:schemeClr>
-            </a:gs>
-            <a:gs pos="35000">
-              <a:schemeClr val="phClr">
-                <a:tint val="37000"/>
-                <a:satMod val="300000"/>
-              </a:schemeClr>
-            </a:gs>
-            <a:gs pos="100000">
-              <a:schemeClr val="phClr">
-                <a:tint val="15000"/>
-                <a:satMod val="350000"/>
-              </a:schemeClr>
-            </a:gs>
-          </a:gsLst>
-          <a:lin ang="16200000" scaled="1"/>
-        </a:gradFill>
-        <a:gradFill rotWithShape="1">
-          <a:gsLst>
-            <a:gs pos="0">
-              <a:schemeClr val="phClr">
-                <a:shade val="51000"/>
-                <a:satMod val="130000"/>
-              </a:schemeClr>
-            </a:gs>
-            <a:gs pos="80000">
-              <a:schemeClr val="phClr">
-                <a:shade val="93000"/>
-                <a:satMod val="130000"/>
-              </a:schemeClr>
-            </a:gs>
-            <a:gs pos="100000">
-              <a:schemeClr val="phClr">
-                <a:shade val="94000"/>
-                <a:satMod val="135000"/>
-              </a:schemeClr>
-            </a:gs>
-          </a:gsLst>
-          <a:lin ang="16200000" scaled="0"/>
-        </a:gradFill>
-      </a:fillStyleLst>
-      <a:lnStyleLst>
-        <a:ln w="9525" cap="flat" cmpd="sng" algn="ctr">
-          <a:solidFill>
-            <a:schemeClr val="phClr">
-              <a:shade val="95000"/>
-              <a:satMod val="105000"/>
-            </a:schemeClr>
-          </a:solidFill>
-          <a:prstDash val="solid"/>
-        </a:ln>
-        <a:ln w="25400" cap="flat" cmpd="sng" algn="ctr">
-          <a:solidFill>
-            <a:schemeClr val="phClr"/>
-          </a:solidFill>
-          <a:prstDash val="solid"/>
-        </a:ln>
-        <a:ln w="38100" cap="flat" cmpd="sng" algn="ctr">
-          <a:solidFill>
-            <a:schemeClr val="phClr"/>
-          </a:solidFill>
-          <a:prstDash val="solid"/>
-        </a:ln>
-      </a:lnStyleLst>
-      <a:effectStyleLst>
-        <a:effectStyle>
-          <a:effectLst/>
-        </a:effectStyle>
-        <a:effectStyle>
-          <a:effectLst/>
-        </a:effectStyle>
-        <a:effectStyle>
-          <a:effectLst/>
-        </a:effectStyle>
-      </a:effectStyleLst>
-      <a:bgFillStyleLst>
-        <a:solidFill>
-          <a:schemeClr val="phClr"/>
-        </a:solidFill>
-        <a:gradFill rotWithShape="1">
-          <a:gsLst>
-            <a:gs pos="0">
-              <a:schemeClr val="phClr">
-                <a:tint val="40000"/>
-                <a:satMod val="350000"/>
-              </a:schemeClr>
-            </a:gs>
-            <a:gs pos="40000">
-              <a:schemeClr val="phClr">
-                <a:tint val="45000"/>
-                <a:shade val="99000"/>
-                <a:satMod val="350000"/>
-              </a:schemeClr>
-            </a:gs>
-            <a:gs pos="100000">
-              <a:schemeClr val="phClr">
-                <a:shade val="20000"/>
-                <a:satMod val="255000"/>
-              </a:schemeClr>
-            </a:gs>
-          </a:gsLst>
-          <a:path path="circle">
-            <a:fillToRect l="50000" t="-80000" r="50000" b="180000"/>
-          </a:path>
-        </a:gradFill>
-        <a:gradFill rotWithShape="1">
-          <a:gsLst>
-            <a:gs pos="0">
-              <a:schemeClr val="phClr">
-                <a:tint val="80000"/>
-                <a:satMod val="300000"/>
-              </a:schemeClr>
-            </a:gs>
-            <a:gs pos="100000">
-              <a:schemeClr val="phClr">
-                <a:shade val="30000"/>
-                <a:satMod val="200000"/>
-              </a:schemeClr>
-            </a:gs>
-          </a:gsLst>
-          <a:path path="circle">
-            <a:fillToRect l="50000" t="50000" r="50000" b="50000"/>
-          </a:path>
-        </a:gradFill>
-      </a:bgFillStyleLst>
-    </a:fmtScheme>
-  </a:themeElements>
-  <a:objectDefaults/>
-  <a:extraClrSchemeLst/>
-</a:theme>
 </file>
</xml_diff>